<commit_message>
Revisão interna 1: planilhas 06/09/10 (histórico de semanas, datas de horas, checklist), modelos de slides corrigidos (dados da Prisma, rodapé neutro, eixo em zero, slide financeiro), gerador de telas em pt-BR, vídeo de vendas parametrizado
Co-Authored-By: Claude Fable 5.1 <noreply@anthropic.com>
Claude-Session: https://claude.ai/code/session_0146uBo6FVJ2cyEehyP8rK61
</commit_message>
<xml_diff>
--- a/projetos/gestao-ia-planilhas/produto/kit-completo/entrega/15-modelo-relatorio-mensal-8-slides.pptx
+++ b/projetos/gestao-ia-planilhas/produto/kit-completo/entrega/15-modelo-relatorio-mensal-8-slides.pptx
@@ -163,6 +163,7 @@
                 </a:pPr>
               </a:p>
             </c:txPr>
+            <c:dLblPos val="outEnd"/>
             <c:showLegendKey val="0"/>
             <c:showVal val="1"/>
             <c:showCatName val="0"/>
@@ -243,6 +244,7 @@
               </a:pPr>
             </a:p>
           </c:txPr>
+          <c:dLblPos val="outEnd"/>
           <c:showLegendKey val="0"/>
           <c:showVal val="1"/>
           <c:showCatName val="0"/>
@@ -257,6 +259,163 @@
         <c:axId val="2094734552"/>
         <c:axId val="2094734556"/>
       </c:barChart>
+      <c:lineChart>
+        <c:varyColors val="0"/>
+        <c:ser>
+          <c:idx val="1"/>
+          <c:order val="1"/>
+          <c:tx>
+            <c:strRef>
+              <c:f>Sheet1!$C$1</c:f>
+              <c:strCache>
+                <c:ptCount val="1"/>
+                <c:pt idx="0">
+                  <c:v>Meta (R$ 120 mil)</c:v>
+                </c:pt>
+              </c:strCache>
+            </c:strRef>
+          </c:tx>
+          <c:spPr>
+            <a:solidFill>
+              <a:srgbClr val="FFC83D"/>
+            </a:solidFill>
+            <a:ln w="25400" cap="flat">
+              <a:solidFill>
+                <a:srgbClr val="FFC83D"/>
+              </a:solidFill>
+              <a:prstDash val="dash"/>
+              <a:round/>
+            </a:ln>
+            <a:effectLst/>
+          </c:spPr>
+          <c:invertIfNegative val="0"/>
+          <c:dLbls>
+            <c:numFmt formatCode="#,##0" sourceLinked="0"/>
+            <c:txPr>
+              <a:bodyPr/>
+              <a:lstStyle/>
+              <a:p>
+                <a:pPr>
+                  <a:defRPr b="0" i="0" strike="noStrike" sz="1200" u="none">
+                    <a:solidFill>
+                      <a:srgbClr val="000000"/>
+                    </a:solidFill>
+                    <a:latin typeface="Arial"/>
+                  </a:defRPr>
+                </a:pPr>
+              </a:p>
+            </c:txPr>
+            <c:showLegendKey val="0"/>
+            <c:showVal val="0"/>
+            <c:showCatName val="0"/>
+            <c:showSerName val="0"/>
+            <c:showPercent val="0"/>
+            <c:showBubbleSize val="0"/>
+            <c:showLeaderLines val="0"/>
+          </c:dLbls>
+          <c:marker>
+            <c:symbol val="none"/>
+            <c:size val="6"/>
+            <c:spPr>
+              <a:solidFill>
+                <a:srgbClr val="FFC83D"/>
+              </a:solidFill>
+              <a:ln w="9525" cap="flat">
+                <a:solidFill>
+                  <a:srgbClr val="FFC83D"/>
+                </a:solidFill>
+                <a:prstDash val="solid"/>
+                <a:round/>
+              </a:ln>
+              <a:effectLst/>
+            </c:spPr>
+          </c:marker>
+          <c:cat>
+            <c:multiLvlStrRef>
+              <c:f>Sheet1!$A$2:$A$7</c:f>
+              <c:multiLvlStrCache>
+                <c:ptCount val="6"/>
+                <c:lvl>
+                  <c:pt idx="0">
+                    <c:v>Abr</c:v>
+                  </c:pt>
+                  <c:pt idx="1">
+                    <c:v>Mai</c:v>
+                  </c:pt>
+                  <c:pt idx="2">
+                    <c:v>Jun</c:v>
+                  </c:pt>
+                  <c:pt idx="3">
+                    <c:v>Jul</c:v>
+                  </c:pt>
+                  <c:pt idx="4">
+                    <c:v>Ago</c:v>
+                  </c:pt>
+                  <c:pt idx="5">
+                    <c:v>Set</c:v>
+                  </c:pt>
+                </c:lvl>
+              </c:multiLvlStrCache>
+            </c:multiLvlStrRef>
+          </c:cat>
+          <c:val>
+            <c:numRef>
+              <c:f>Sheet1!$C$2:$C$7</c:f>
+              <c:numCache>
+                <c:formatCode>General</c:formatCode>
+                <c:ptCount val="6"/>
+                <c:pt idx="0">
+                  <c:v>120</c:v>
+                </c:pt>
+                <c:pt idx="1">
+                  <c:v>120</c:v>
+                </c:pt>
+                <c:pt idx="2">
+                  <c:v>120</c:v>
+                </c:pt>
+                <c:pt idx="3">
+                  <c:v>120</c:v>
+                </c:pt>
+                <c:pt idx="4">
+                  <c:v>120</c:v>
+                </c:pt>
+                <c:pt idx="5">
+                  <c:v>120</c:v>
+                </c:pt>
+              </c:numCache>
+            </c:numRef>
+          </c:val>
+          <c:smooth val="0"/>
+        </c:ser>
+        <c:dLbls>
+          <c:numFmt formatCode="#,##0" sourceLinked="0"/>
+          <c:txPr>
+            <a:bodyPr/>
+            <a:lstStyle/>
+            <a:p>
+              <a:pPr>
+                <a:defRPr b="0" i="0" strike="noStrike" sz="1200" u="none">
+                  <a:solidFill>
+                    <a:srgbClr val="000000"/>
+                  </a:solidFill>
+                  <a:latin typeface="Arial"/>
+                </a:defRPr>
+              </a:pPr>
+            </a:p>
+          </c:txPr>
+          <c:showLegendKey val="0"/>
+          <c:showVal val="0"/>
+          <c:showCatName val="0"/>
+          <c:showSerName val="0"/>
+          <c:showPercent val="0"/>
+          <c:showBubbleSize val="0"/>
+          <c:showLeaderLines val="0"/>
+        </c:dLbls>
+        <c:marker val="1"/>
+        <c:axId val="2094734554"/>
+        <c:axId val="2094734552"/>
+        <c:axId val="2094734556"/>
+      </c:lineChart>
       <c:catAx>
         <c:axId val="2094734554"/>
         <c:scaling>
@@ -302,8 +461,8 @@
         <c:axId val="2094734552"/>
         <c:scaling>
           <c:orientation val="minMax"/>
-          <c:max val="140"/>
-          <c:min val="90"/>
+          <c:max val="150"/>
+          <c:min val="0"/>
         </c:scaling>
         <c:delete val="0"/>
         <c:axPos val="l"/>
@@ -349,6 +508,7 @@
         <c:crossAx val="2094734554"/>
         <c:crosses val="autoZero"/>
         <c:crossBetween val="between"/>
+        <c:majorUnit val="30"/>
       </c:valAx>
       <c:spPr>
         <a:noFill/>
@@ -358,6 +518,20 @@
         <a:effectLst/>
       </c:spPr>
     </c:plotArea>
+    <c:legend>
+      <c:legendPos val="b"/>
+      <c:overlay val="0"/>
+      <c:txPr>
+        <a:bodyPr/>
+        <a:lstStyle/>
+        <a:p>
+          <a:pPr>
+            <a:defRPr sz="1000">      </a:defRPr>
+          </a:pPr>
+          <a:endParaRPr lang="en-US"/>
+        </a:p>
+      </c:txPr>
+    </c:legend>
     <c:plotVisOnly val="1"/>
     <c:dispBlanksAs val="span"/>
   </c:chart>
@@ -1191,7 +1365,7 @@
           <a:p>
             <a:r>
               <a:rPr lang="en-US" dirty="0"/>
-              <a:t>Capa. Troque mês, empresa, público e data. A frase em itálico é a conclusão do mês em uma linha: escreva por último.</a:t>
+              <a:t>Modelo do Seu Sócio Gestor: troque os textos e mantenha a estrutura. Capa. Troque mês, empresa, público e data. A frase em itálico é a conclusão do mês em uma linha: escreva por último.</a:t>
             </a:r>
             <a:endParaRPr lang="en-US" dirty="0"/>
           </a:p>
@@ -1367,7 +1541,7 @@
           <a:p>
             <a:r>
               <a:rPr lang="en-US" dirty="0"/>
-              <a:t>Destaque positivo com gráfico. Clique no gráfico &gt; Editar dados para trocar os valores. Mantenha a linha da meta.</a:t>
+              <a:t>Destaque positivo com gráfico. Clique no gráfico &gt; Editar dados para trocar os valores; a meta é a série tracejada, troque os 120 pelo seu número.</a:t>
             </a:r>
             <a:endParaRPr lang="en-US" dirty="0"/>
           </a:p>
@@ -2411,8 +2585,8 @@
         </p:nvSpPr>
         <p:spPr>
           <a:xfrm>
-            <a:off x="457200" y="4773168"/>
-            <a:ext cx="6858000" cy="228600"/>
+            <a:off x="457200" y="4791456"/>
+            <a:ext cx="6858000" cy="201168"/>
           </a:xfrm>
           <a:prstGeom prst="rect">
             <a:avLst/>
@@ -2428,17 +2602,17 @@
               <a:buNone/>
             </a:pPr>
             <a:r>
-              <a:rPr lang="en-US" sz="800" dirty="0">
-                <a:solidFill>
-                  <a:srgbClr val="B89BE0"/>
+              <a:rPr lang="en-US" sz="700" dirty="0">
+                <a:solidFill>
+                  <a:srgbClr val="7A5AA8"/>
                 </a:solidFill>
                 <a:latin typeface="Arial" pitchFamily="34" charset="0"/>
                 <a:ea typeface="Arial" pitchFamily="34" charset="-122"/>
                 <a:cs typeface="Arial" pitchFamily="34" charset="-120"/>
               </a:rPr>
-              <a:t>Kit IA no Trabalho · Essencial · modelo do Seu Sócio Gestor. Troque os textos; mantenha a estrutura.</a:t>
-            </a:r>
-            <a:endParaRPr lang="en-US" sz="800" dirty="0"/>
+              <a:t>Kit IA no Trabalho · modelo v1.0 · set/2026</a:t>
+            </a:r>
+            <a:endParaRPr lang="en-US" sz="700" dirty="0"/>
           </a:p>
         </p:txBody>
       </p:sp>
@@ -3145,8 +3319,8 @@
         </p:nvSpPr>
         <p:spPr>
           <a:xfrm>
-            <a:off x="457200" y="4773168"/>
-            <a:ext cx="6858000" cy="228600"/>
+            <a:off x="457200" y="4791456"/>
+            <a:ext cx="6858000" cy="201168"/>
           </a:xfrm>
           <a:prstGeom prst="rect">
             <a:avLst/>
@@ -3162,17 +3336,17 @@
               <a:buNone/>
             </a:pPr>
             <a:r>
-              <a:rPr lang="en-US" sz="800" dirty="0">
-                <a:solidFill>
-                  <a:srgbClr val="7A5AA8"/>
+              <a:rPr lang="en-US" sz="700" dirty="0">
+                <a:solidFill>
+                  <a:srgbClr val="B89BE0"/>
                 </a:solidFill>
                 <a:latin typeface="Arial" pitchFamily="34" charset="0"/>
                 <a:ea typeface="Arial" pitchFamily="34" charset="-122"/>
                 <a:cs typeface="Arial" pitchFamily="34" charset="-120"/>
               </a:rPr>
-              <a:t>Kit IA no Trabalho · Essencial · modelo do Seu Sócio Gestor. Troque os textos; mantenha a estrutura.</a:t>
-            </a:r>
-            <a:endParaRPr lang="en-US" sz="800" dirty="0"/>
+              <a:t>Kit IA no Trabalho · modelo v1.0 · set/2026</a:t>
+            </a:r>
+            <a:endParaRPr lang="en-US" sz="700" dirty="0"/>
           </a:p>
         </p:txBody>
       </p:sp>
@@ -3349,7 +3523,7 @@
                 <a:ea typeface="Arial" pitchFamily="34" charset="-122"/>
                 <a:cs typeface="Arial" pitchFamily="34" charset="-120"/>
               </a:rPr>
-              <a:t>Receita cresceu pelo terceiro mês seguido e passou a meta</a:t>
+              <a:t>Receita cresceu pelo segundo mês seguido e passou a meta</a:t>
             </a:r>
             <a:endParaRPr lang="en-US" sz="2600" dirty="0"/>
           </a:p>
@@ -3412,69 +3586,7 @@
       </p:graphicFrame>
       <p:sp>
         <p:nvSpPr>
-          <p:cNvPr id="5" name="Shape 2"/>
-          <p:cNvSpPr/>
-          <p:nvPr/>
-        </p:nvSpPr>
-        <p:spPr>
-          <a:xfrm>
-            <a:off x="868680" y="2651760"/>
-            <a:ext cx="4480560" cy="0"/>
-          </a:xfrm>
-          <a:prstGeom prst="line">
-            <a:avLst/>
-          </a:prstGeom>
-          <a:noFill/>
-          <a:ln w="25400">
-            <a:solidFill>
-              <a:srgbClr val="FFC83D"/>
-            </a:solidFill>
-            <a:prstDash val="dash"/>
-          </a:ln>
-        </p:spPr>
-      </p:sp>
-      <p:sp>
-        <p:nvSpPr>
-          <p:cNvPr id="6" name="Text 3"/>
-          <p:cNvSpPr txBox="1"/>
-          <p:nvPr/>
-        </p:nvSpPr>
-        <p:spPr>
-          <a:xfrm>
-            <a:off x="868680" y="2395728"/>
-            <a:ext cx="1280160" cy="228600"/>
-          </a:xfrm>
-          <a:prstGeom prst="rect">
-            <a:avLst/>
-          </a:prstGeom>
-          <a:noFill/>
-          <a:ln/>
-        </p:spPr>
-        <p:txBody>
-          <a:bodyPr wrap="square" lIns="0" tIns="0" rIns="0" bIns="0" rtlCol="0" anchor="ctr"/>
-          <a:lstStyle/>
-          <a:p>
-            <a:pPr indent="0" marL="0">
-              <a:buNone/>
-            </a:pPr>
-            <a:r>
-              <a:rPr lang="en-US" sz="900" dirty="0">
-                <a:solidFill>
-                  <a:srgbClr val="5A4A78"/>
-                </a:solidFill>
-                <a:latin typeface="Arial" pitchFamily="34" charset="0"/>
-                <a:ea typeface="Arial" pitchFamily="34" charset="-122"/>
-                <a:cs typeface="Arial" pitchFamily="34" charset="-120"/>
-              </a:rPr>
-              <a:t>meta R$ 120 mil</a:t>
-            </a:r>
-            <a:endParaRPr lang="en-US" sz="900" dirty="0"/>
-          </a:p>
-        </p:txBody>
-      </p:sp>
-      <p:sp>
-        <p:nvSpPr>
-          <p:cNvPr id="7" name="Text 4"/>
+          <p:cNvPr id="5" name="Text 2"/>
           <p:cNvSpPr txBox="1"/>
           <p:nvPr/>
         </p:nvSpPr>
@@ -3571,7 +3683,7 @@
                 <a:ea typeface="Arial" pitchFamily="34" charset="-122"/>
                 <a:cs typeface="Arial" pitchFamily="34" charset="-120"/>
               </a:rPr>
-              <a:t>Serviços foram 95% da receita; produtos começaram (R$ 320).</a:t>
+              <a:t>Contratos mensais seguraram a base; dois projetos grandes fecharam o mês.</a:t>
             </a:r>
             <a:endParaRPr lang="en-US" sz="1200" dirty="0"/>
           </a:p>
@@ -3579,14 +3691,14 @@
       </p:sp>
       <p:sp>
         <p:nvSpPr>
-          <p:cNvPr id="8" name="Text 5"/>
+          <p:cNvPr id="6" name="Text 3"/>
           <p:cNvSpPr txBox="1"/>
           <p:nvPr/>
         </p:nvSpPr>
         <p:spPr>
           <a:xfrm>
-            <a:off x="457200" y="4773168"/>
-            <a:ext cx="6858000" cy="228600"/>
+            <a:off x="457200" y="4791456"/>
+            <a:ext cx="6858000" cy="201168"/>
           </a:xfrm>
           <a:prstGeom prst="rect">
             <a:avLst/>
@@ -3602,23 +3714,23 @@
               <a:buNone/>
             </a:pPr>
             <a:r>
-              <a:rPr lang="en-US" sz="800" dirty="0">
-                <a:solidFill>
-                  <a:srgbClr val="7A5AA8"/>
+              <a:rPr lang="en-US" sz="700" dirty="0">
+                <a:solidFill>
+                  <a:srgbClr val="B89BE0"/>
                 </a:solidFill>
                 <a:latin typeface="Arial" pitchFamily="34" charset="0"/>
                 <a:ea typeface="Arial" pitchFamily="34" charset="-122"/>
                 <a:cs typeface="Arial" pitchFamily="34" charset="-120"/>
               </a:rPr>
-              <a:t>Kit IA no Trabalho · Essencial · modelo do Seu Sócio Gestor. Troque os textos; mantenha a estrutura.</a:t>
-            </a:r>
-            <a:endParaRPr lang="en-US" sz="800" dirty="0"/>
-          </a:p>
-        </p:txBody>
-      </p:sp>
-      <p:sp>
-        <p:nvSpPr>
-          <p:cNvPr id="9" name="Shape 6"/>
+              <a:t>Kit IA no Trabalho · modelo v1.0 · set/2026</a:t>
+            </a:r>
+            <a:endParaRPr lang="en-US" sz="700" dirty="0"/>
+          </a:p>
+        </p:txBody>
+      </p:sp>
+      <p:sp>
+        <p:nvSpPr>
+          <p:cNvPr id="7" name="Shape 4"/>
           <p:cNvSpPr/>
           <p:nvPr/>
         </p:nvSpPr>
@@ -3645,7 +3757,7 @@
       </p:sp>
       <p:sp>
         <p:nvSpPr>
-          <p:cNvPr id="10" name="Shape 7"/>
+          <p:cNvPr id="8" name="Shape 5"/>
           <p:cNvSpPr/>
           <p:nvPr/>
         </p:nvSpPr>
@@ -3672,7 +3784,7 @@
       </p:sp>
       <p:sp>
         <p:nvSpPr>
-          <p:cNvPr id="11" name="Shape 8"/>
+          <p:cNvPr id="9" name="Shape 6"/>
           <p:cNvSpPr/>
           <p:nvPr/>
         </p:nvSpPr>
@@ -3699,7 +3811,7 @@
       </p:sp>
       <p:sp>
         <p:nvSpPr>
-          <p:cNvPr id="12" name="Shape 9"/>
+          <p:cNvPr id="10" name="Shape 7"/>
           <p:cNvSpPr/>
           <p:nvPr/>
         </p:nvSpPr>
@@ -4091,8 +4203,8 @@
         </p:nvSpPr>
         <p:spPr>
           <a:xfrm>
-            <a:off x="457200" y="4773168"/>
-            <a:ext cx="6858000" cy="228600"/>
+            <a:off x="457200" y="4791456"/>
+            <a:ext cx="6858000" cy="201168"/>
           </a:xfrm>
           <a:prstGeom prst="rect">
             <a:avLst/>
@@ -4108,17 +4220,17 @@
               <a:buNone/>
             </a:pPr>
             <a:r>
-              <a:rPr lang="en-US" sz="800" dirty="0">
-                <a:solidFill>
-                  <a:srgbClr val="7A5AA8"/>
+              <a:rPr lang="en-US" sz="700" dirty="0">
+                <a:solidFill>
+                  <a:srgbClr val="B89BE0"/>
                 </a:solidFill>
                 <a:latin typeface="Arial" pitchFamily="34" charset="0"/>
                 <a:ea typeface="Arial" pitchFamily="34" charset="-122"/>
                 <a:cs typeface="Arial" pitchFamily="34" charset="-120"/>
               </a:rPr>
-              <a:t>Kit IA no Trabalho · Essencial · modelo do Seu Sócio Gestor. Troque os textos; mantenha a estrutura.</a:t>
-            </a:r>
-            <a:endParaRPr lang="en-US" sz="800" dirty="0"/>
+              <a:t>Kit IA no Trabalho · modelo v1.0 · set/2026</a:t>
+            </a:r>
+            <a:endParaRPr lang="en-US" sz="700" dirty="0"/>
           </a:p>
         </p:txBody>
       </p:sp>
@@ -4439,7 +4551,7 @@
                 <a:ea typeface="Arial" pitchFamily="34" charset="-122"/>
                 <a:cs typeface="Arial" pitchFamily="34" charset="-120"/>
               </a:rPr>
-              <a:t>Despesas +3% em setembro e +6% acima da meta. Alimentação, transporte e educação subiram.</a:t>
+              <a:t>Despesas +3% contra agosto e 6% acima da meta de R$ 85 mil. Freelancers, mídia paga e softwares subiram.</a:t>
             </a:r>
             <a:endParaRPr lang="en-US" sz="1200" dirty="0"/>
           </a:p>
@@ -4544,7 +4656,7 @@
                 <a:ea typeface="Arial" pitchFamily="34" charset="-122"/>
                 <a:cs typeface="Arial" pitchFamily="34" charset="-120"/>
               </a:rPr>
-              <a:t>Curso de motion (R$ 297) e dois eventos com equipe. Parte é pontual, parte é reajuste de fornecedores.</a:t>
+              <a:t>Freelancers extras na campanha de um cliente grande e um teste novo de anúncios. Parte é pontual; as assinaturas novas ficam.</a:t>
             </a:r>
             <a:endParaRPr lang="en-US" sz="1200" dirty="0"/>
           </a:p>
@@ -4649,7 +4761,7 @@
                 <a:ea typeface="Arial" pitchFamily="34" charset="-122"/>
                 <a:cs typeface="Arial" pitchFamily="34" charset="-120"/>
               </a:rPr>
-              <a:t>Congelar novas assinaturas até dezembro; renegociar dois fornecedores; revisar a meta para R$ 88 mil.</a:t>
+              <a:t>Congelar assinaturas novas até dezembro; mídia só com meta de conversão; revisar a meta para R$ 88 mil.</a:t>
             </a:r>
             <a:endParaRPr lang="en-US" sz="1200" dirty="0"/>
           </a:p>
@@ -4663,8 +4775,8 @@
         </p:nvSpPr>
         <p:spPr>
           <a:xfrm>
-            <a:off x="457200" y="4773168"/>
-            <a:ext cx="6858000" cy="228600"/>
+            <a:off x="457200" y="4791456"/>
+            <a:ext cx="6858000" cy="201168"/>
           </a:xfrm>
           <a:prstGeom prst="rect">
             <a:avLst/>
@@ -4680,17 +4792,17 @@
               <a:buNone/>
             </a:pPr>
             <a:r>
-              <a:rPr lang="en-US" sz="800" dirty="0">
-                <a:solidFill>
-                  <a:srgbClr val="7A5AA8"/>
+              <a:rPr lang="en-US" sz="700" dirty="0">
+                <a:solidFill>
+                  <a:srgbClr val="B89BE0"/>
                 </a:solidFill>
                 <a:latin typeface="Arial" pitchFamily="34" charset="0"/>
                 <a:ea typeface="Arial" pitchFamily="34" charset="-122"/>
                 <a:cs typeface="Arial" pitchFamily="34" charset="-120"/>
               </a:rPr>
-              <a:t>Kit IA no Trabalho · Essencial · modelo do Seu Sócio Gestor. Troque os textos; mantenha a estrutura.</a:t>
-            </a:r>
-            <a:endParaRPr lang="en-US" sz="800" dirty="0"/>
+              <a:t>Kit IA no Trabalho · modelo v1.0 · set/2026</a:t>
+            </a:r>
+            <a:endParaRPr lang="en-US" sz="700" dirty="0"/>
           </a:p>
         </p:txBody>
       </p:sp>
@@ -5040,8 +5152,8 @@
         </p:nvSpPr>
         <p:spPr>
           <a:xfrm>
-            <a:off x="457200" y="4773168"/>
-            <a:ext cx="6858000" cy="228600"/>
+            <a:off x="457200" y="4791456"/>
+            <a:ext cx="6858000" cy="201168"/>
           </a:xfrm>
           <a:prstGeom prst="rect">
             <a:avLst/>
@@ -5057,17 +5169,17 @@
               <a:buNone/>
             </a:pPr>
             <a:r>
-              <a:rPr lang="en-US" sz="800" dirty="0">
-                <a:solidFill>
-                  <a:srgbClr val="7A5AA8"/>
+              <a:rPr lang="en-US" sz="700" dirty="0">
+                <a:solidFill>
+                  <a:srgbClr val="B89BE0"/>
                 </a:solidFill>
                 <a:latin typeface="Arial" pitchFamily="34" charset="0"/>
                 <a:ea typeface="Arial" pitchFamily="34" charset="-122"/>
                 <a:cs typeface="Arial" pitchFamily="34" charset="-120"/>
               </a:rPr>
-              <a:t>Kit IA no Trabalho · Essencial · modelo do Seu Sócio Gestor. Troque os textos; mantenha a estrutura.</a:t>
-            </a:r>
-            <a:endParaRPr lang="en-US" sz="800" dirty="0"/>
+              <a:t>Kit IA no Trabalho · modelo v1.0 · set/2026</a:t>
+            </a:r>
+            <a:endParaRPr lang="en-US" sz="700" dirty="0"/>
           </a:p>
         </p:txBody>
       </p:sp>
@@ -5413,7 +5525,7 @@
                 <a:ea typeface="Arial" pitchFamily="34" charset="-122"/>
                 <a:cs typeface="Arial" pitchFamily="34" charset="-120"/>
               </a:rPr>
-              <a:t>Renegociar dois fornecedores de alimentação e transporte</a:t>
+              <a:t>Renegociar os dois freelancers fixos e cancelar softwares sem uso</a:t>
             </a:r>
             <a:endParaRPr lang="en-US" sz="1400" dirty="0"/>
           </a:p>
@@ -5804,8 +5916,8 @@
         </p:nvSpPr>
         <p:spPr>
           <a:xfrm>
-            <a:off x="457200" y="4773168"/>
-            <a:ext cx="6858000" cy="228600"/>
+            <a:off x="457200" y="4791456"/>
+            <a:ext cx="6858000" cy="201168"/>
           </a:xfrm>
           <a:prstGeom prst="rect">
             <a:avLst/>
@@ -5821,17 +5933,17 @@
               <a:buNone/>
             </a:pPr>
             <a:r>
-              <a:rPr lang="en-US" sz="800" dirty="0">
-                <a:solidFill>
-                  <a:srgbClr val="7A5AA8"/>
+              <a:rPr lang="en-US" sz="700" dirty="0">
+                <a:solidFill>
+                  <a:srgbClr val="B89BE0"/>
                 </a:solidFill>
                 <a:latin typeface="Arial" pitchFamily="34" charset="0"/>
                 <a:ea typeface="Arial" pitchFamily="34" charset="-122"/>
                 <a:cs typeface="Arial" pitchFamily="34" charset="-120"/>
               </a:rPr>
-              <a:t>Kit IA no Trabalho · Essencial · modelo do Seu Sócio Gestor. Troque os textos; mantenha a estrutura.</a:t>
-            </a:r>
-            <a:endParaRPr lang="en-US" sz="800" dirty="0"/>
+              <a:t>Kit IA no Trabalho · modelo v1.0 · set/2026</a:t>
+            </a:r>
+            <a:endParaRPr lang="en-US" sz="700" dirty="0"/>
           </a:p>
         </p:txBody>
       </p:sp>
@@ -6297,8 +6409,8 @@
         </p:nvSpPr>
         <p:spPr>
           <a:xfrm>
-            <a:off x="457200" y="4773168"/>
-            <a:ext cx="6858000" cy="228600"/>
+            <a:off x="457200" y="4791456"/>
+            <a:ext cx="6858000" cy="201168"/>
           </a:xfrm>
           <a:prstGeom prst="rect">
             <a:avLst/>
@@ -6314,17 +6426,17 @@
               <a:buNone/>
             </a:pPr>
             <a:r>
-              <a:rPr lang="en-US" sz="800" dirty="0">
-                <a:solidFill>
-                  <a:srgbClr val="B89BE0"/>
+              <a:rPr lang="en-US" sz="700" dirty="0">
+                <a:solidFill>
+                  <a:srgbClr val="7A5AA8"/>
                 </a:solidFill>
                 <a:latin typeface="Arial" pitchFamily="34" charset="0"/>
                 <a:ea typeface="Arial" pitchFamily="34" charset="-122"/>
                 <a:cs typeface="Arial" pitchFamily="34" charset="-120"/>
               </a:rPr>
-              <a:t>Kit IA no Trabalho · Essencial · modelo do Seu Sócio Gestor. Troque os textos; mantenha a estrutura.</a:t>
-            </a:r>
-            <a:endParaRPr lang="en-US" sz="800" dirty="0"/>
+              <a:t>Kit IA no Trabalho · modelo v1.0 · set/2026</a:t>
+            </a:r>
+            <a:endParaRPr lang="en-US" sz="700" dirty="0"/>
           </a:p>
         </p:txBody>
       </p:sp>

</xml_diff>